<commit_message>
feat(pptx): align palette with DS design guide + fix dashboard drift
- accent: #0017C1 (key-900) -> #0031D8 (key-800), the デジタル庁 HP 基調
  primary blue, matching styles/tokens.semantic.css and docs/requirements.md
- dashboard highlight tile: solid-blue fill -> gray surface + accent top
  border + accent value, mirroring `.tile--highlight` (blue over gray)
- add CAT (DS dashboard 7-palette) and THEME map to tokens.mjs
- patch ppt/theme/theme1.xml via applyDsTheme() so shapes/charts inserted
  later in PowerPoint default to DS blue (accent1) instead of Office #4472C4;
  accent2-6 = DS series colors, text2/bg2 = DS gray ramp
- fix dashboard KPI drift vs HTML deck: コンポーネント 12->20 (自作14+公式6),
  付録スライド 5->8
- declare jszip as an explicit devDependency

Co-Authored-By: Claude Opus 4.8 <noreply@anthropic.com>
</commit_message>
<xml_diff>
--- a/dist/sample-deck.pptx
+++ b/dist/sample-deck.pptx
@@ -2548,7 +2548,7 @@
     <p:bg>
       <p:bgPr>
         <a:solidFill>
-          <a:srgbClr val="0017C1"/>
+          <a:srgbClr val="0031D8"/>
         </a:solidFill>
       </p:bgPr>
     </p:bg>
@@ -2919,7 +2919,7 @@
             <a:r>
               <a:rPr lang="en-US" sz="2700" b="1" dirty="0">
                 <a:solidFill>
-                  <a:srgbClr val="0017C1"/>
+                  <a:srgbClr val="0031D8"/>
                 </a:solidFill>
                 <a:latin typeface="Noto Sans JP" pitchFamily="34" charset="0"/>
                 <a:ea typeface="Noto Sans JP" pitchFamily="34" charset="-122"/>
@@ -3023,7 +3023,7 @@
             <a:avLst/>
           </a:prstGeom>
           <a:solidFill>
-            <a:srgbClr val="0017C1"/>
+            <a:srgbClr val="0031D8"/>
           </a:solidFill>
           <a:ln/>
         </p:spPr>
@@ -3219,7 +3219,7 @@
             <a:avLst/>
           </a:prstGeom>
           <a:solidFill>
-            <a:srgbClr val="0017C1"/>
+            <a:srgbClr val="0031D8"/>
           </a:solidFill>
           <a:ln/>
         </p:spPr>
@@ -3290,7 +3290,7 @@
             <a:r>
               <a:rPr lang="en-US" sz="1050" b="1" dirty="0">
                 <a:solidFill>
-                  <a:srgbClr val="0017C1"/>
+                  <a:srgbClr val="0031D8"/>
                 </a:solidFill>
                 <a:latin typeface="Noto Sans JP" pitchFamily="34" charset="0"/>
                 <a:ea typeface="Noto Sans JP" pitchFamily="34" charset="-122"/>
@@ -3932,7 +3932,7 @@
             <a:r>
               <a:rPr lang="en-US" sz="2700" b="1" dirty="0">
                 <a:solidFill>
-                  <a:srgbClr val="0017C1"/>
+                  <a:srgbClr val="0031D8"/>
                 </a:solidFill>
                 <a:latin typeface="Noto Sans JP" pitchFamily="34" charset="0"/>
                 <a:ea typeface="Noto Sans JP" pitchFamily="34" charset="-122"/>
@@ -3999,7 +3999,7 @@
           </a:solidFill>
           <a:ln w="25400">
             <a:solidFill>
-              <a:srgbClr val="0017C1"/>
+              <a:srgbClr val="0031D8"/>
             </a:solidFill>
             <a:prstDash val="solid"/>
           </a:ln>
@@ -4020,7 +4020,7 @@
             <a:avLst/>
           </a:prstGeom>
           <a:solidFill>
-            <a:srgbClr val="0017C1"/>
+            <a:srgbClr val="0031D8"/>
           </a:solidFill>
           <a:ln/>
         </p:spPr>
@@ -4052,7 +4052,7 @@
             <a:r>
               <a:rPr lang="en-US" sz="1500" b="1" dirty="0">
                 <a:solidFill>
-                  <a:srgbClr val="0017C1"/>
+                  <a:srgbClr val="0031D8"/>
                 </a:solidFill>
                 <a:latin typeface="Noto Sans JP" pitchFamily="34" charset="0"/>
                 <a:ea typeface="Noto Sans JP" pitchFamily="34" charset="-122"/>
@@ -4748,7 +4748,7 @@
             <a:r>
               <a:rPr lang="en-US" sz="2700" b="1" dirty="0">
                 <a:solidFill>
-                  <a:srgbClr val="0017C1"/>
+                  <a:srgbClr val="0031D8"/>
                 </a:solidFill>
                 <a:latin typeface="Noto Sans JP" pitchFamily="34" charset="0"/>
                 <a:ea typeface="Noto Sans JP" pitchFamily="34" charset="-122"/>
@@ -4843,7 +4843,7 @@
             <a:r>
               <a:rPr lang="en-US" sz="2700" b="1" dirty="0">
                 <a:solidFill>
-                  <a:srgbClr val="0017C1"/>
+                  <a:srgbClr val="0031D8"/>
                 </a:solidFill>
                 <a:latin typeface="Noto Sans JP" pitchFamily="34" charset="0"/>
                 <a:ea typeface="Noto Sans JP" pitchFamily="34" charset="-122"/>
@@ -4960,7 +4960,7 @@
             <a:r>
               <a:rPr lang="en-US" sz="2700" b="1" dirty="0">
                 <a:solidFill>
-                  <a:srgbClr val="0017C1"/>
+                  <a:srgbClr val="0031D8"/>
                 </a:solidFill>
                 <a:latin typeface="Noto Sans JP" pitchFamily="34" charset="0"/>
                 <a:ea typeface="Noto Sans JP" pitchFamily="34" charset="-122"/>
@@ -5021,7 +5021,7 @@
             <a:r>
               <a:rPr lang="en-US" sz="2700" b="1" dirty="0">
                 <a:solidFill>
-                  <a:srgbClr val="0017C1"/>
+                  <a:srgbClr val="0031D8"/>
                 </a:solidFill>
                 <a:latin typeface="Noto Sans JP" pitchFamily="34" charset="0"/>
                 <a:ea typeface="Noto Sans JP" pitchFamily="34" charset="-122"/>
@@ -5138,7 +5138,7 @@
             <a:r>
               <a:rPr lang="en-US" sz="2700" b="1" dirty="0">
                 <a:solidFill>
-                  <a:srgbClr val="0017C1"/>
+                  <a:srgbClr val="0031D8"/>
                 </a:solidFill>
                 <a:latin typeface="Noto Sans JP" pitchFamily="34" charset="0"/>
                 <a:ea typeface="Noto Sans JP" pitchFamily="34" charset="-122"/>
@@ -5199,7 +5199,7 @@
             <a:r>
               <a:rPr lang="en-US" sz="2700" b="1" dirty="0">
                 <a:solidFill>
-                  <a:srgbClr val="0017C1"/>
+                  <a:srgbClr val="0031D8"/>
                 </a:solidFill>
                 <a:latin typeface="Noto Sans JP" pitchFamily="34" charset="0"/>
                 <a:ea typeface="Noto Sans JP" pitchFamily="34" charset="-122"/>
@@ -5527,7 +5527,7 @@
             <a:r>
               <a:rPr lang="en-US" sz="9600" b="1" dirty="0">
                 <a:solidFill>
-                  <a:srgbClr val="0017C1"/>
+                  <a:srgbClr val="0031D8"/>
                 </a:solidFill>
                 <a:latin typeface="Noto Sans JP" pitchFamily="34" charset="0"/>
                 <a:ea typeface="Noto Sans JP" pitchFamily="34" charset="-122"/>
@@ -6083,7 +6083,7 @@
     <p:bg>
       <p:bgPr>
         <a:solidFill>
-          <a:srgbClr val="0017C1"/>
+          <a:srgbClr val="0031D8"/>
         </a:solidFill>
       </p:bgPr>
     </p:bg>
@@ -6522,7 +6522,7 @@
             <a:r>
               <a:rPr lang="en-US" sz="1050" b="1" dirty="0">
                 <a:solidFill>
-                  <a:srgbClr val="0017C1"/>
+                  <a:srgbClr val="0031D8"/>
                 </a:solidFill>
                 <a:latin typeface="Noto Sans JP" pitchFamily="34" charset="0"/>
                 <a:ea typeface="Noto Sans JP" pitchFamily="34" charset="-122"/>
@@ -6557,7 +6557,7 @@
             <a:r>
               <a:rPr lang="en-US" sz="1050" b="1" dirty="0">
                 <a:solidFill>
-                  <a:srgbClr val="0017C1"/>
+                  <a:srgbClr val="0031D8"/>
                 </a:solidFill>
                 <a:latin typeface="Noto Sans JP" pitchFamily="34" charset="0"/>
                 <a:ea typeface="Noto Sans JP" pitchFamily="34" charset="-122"/>
@@ -6592,7 +6592,7 @@
             <a:r>
               <a:rPr lang="en-US" sz="1050" b="1" dirty="0">
                 <a:solidFill>
-                  <a:srgbClr val="0017C1"/>
+                  <a:srgbClr val="0031D8"/>
                 </a:solidFill>
                 <a:latin typeface="Noto Sans JP" pitchFamily="34" charset="0"/>
                 <a:ea typeface="Noto Sans JP" pitchFamily="34" charset="-122"/>
@@ -6627,7 +6627,7 @@
             <a:r>
               <a:rPr lang="en-US" sz="1050" b="1" dirty="0">
                 <a:solidFill>
-                  <a:srgbClr val="0017C1"/>
+                  <a:srgbClr val="0031D8"/>
                 </a:solidFill>
                 <a:latin typeface="Noto Sans JP" pitchFamily="34" charset="0"/>
                 <a:ea typeface="Noto Sans JP" pitchFamily="34" charset="-122"/>
@@ -6662,7 +6662,7 @@
             <a:r>
               <a:rPr lang="en-US" sz="1050" b="1" dirty="0">
                 <a:solidFill>
-                  <a:srgbClr val="0017C1"/>
+                  <a:srgbClr val="0031D8"/>
                 </a:solidFill>
                 <a:latin typeface="Noto Sans JP" pitchFamily="34" charset="0"/>
                 <a:ea typeface="Noto Sans JP" pitchFamily="34" charset="-122"/>
@@ -6722,7 +6722,7 @@
             <a:r>
               <a:rPr lang="en-US" sz="1050" b="1" dirty="0">
                 <a:solidFill>
-                  <a:srgbClr val="0017C1"/>
+                  <a:srgbClr val="0031D8"/>
                 </a:solidFill>
                 <a:latin typeface="Noto Sans JP" pitchFamily="34" charset="0"/>
                 <a:ea typeface="Noto Sans JP" pitchFamily="34" charset="-122"/>
@@ -6757,7 +6757,7 @@
             <a:r>
               <a:rPr lang="en-US" sz="1050" b="1" dirty="0">
                 <a:solidFill>
-                  <a:srgbClr val="0017C1"/>
+                  <a:srgbClr val="0031D8"/>
                 </a:solidFill>
                 <a:latin typeface="Noto Sans JP" pitchFamily="34" charset="0"/>
                 <a:ea typeface="Noto Sans JP" pitchFamily="34" charset="-122"/>
@@ -6792,7 +6792,7 @@
             <a:r>
               <a:rPr lang="en-US" sz="1050" b="1" dirty="0">
                 <a:solidFill>
-                  <a:srgbClr val="0017C1"/>
+                  <a:srgbClr val="0031D8"/>
                 </a:solidFill>
                 <a:latin typeface="Noto Sans JP" pitchFamily="34" charset="0"/>
                 <a:ea typeface="Noto Sans JP" pitchFamily="34" charset="-122"/>
@@ -6827,7 +6827,7 @@
             <a:r>
               <a:rPr lang="en-US" sz="1050" b="1" dirty="0">
                 <a:solidFill>
-                  <a:srgbClr val="0017C1"/>
+                  <a:srgbClr val="0031D8"/>
                 </a:solidFill>
                 <a:latin typeface="Noto Sans JP" pitchFamily="34" charset="0"/>
                 <a:ea typeface="Noto Sans JP" pitchFamily="34" charset="-122"/>
@@ -6862,7 +6862,7 @@
             <a:r>
               <a:rPr lang="en-US" sz="1050" b="1" dirty="0">
                 <a:solidFill>
-                  <a:srgbClr val="0017C1"/>
+                  <a:srgbClr val="0031D8"/>
                 </a:solidFill>
                 <a:latin typeface="Noto Sans JP" pitchFamily="34" charset="0"/>
                 <a:ea typeface="Noto Sans JP" pitchFamily="34" charset="-122"/>
@@ -7144,7 +7144,7 @@
             <a:r>
               <a:rPr lang="en-US" sz="2700" b="1" dirty="0">
                 <a:solidFill>
-                  <a:srgbClr val="0017C1"/>
+                  <a:srgbClr val="0031D8"/>
                 </a:solidFill>
                 <a:latin typeface="Noto Sans JP" pitchFamily="34" charset="0"/>
                 <a:ea typeface="Noto Sans JP" pitchFamily="34" charset="-122"/>
@@ -7264,7 +7264,7 @@
             <a:avLst/>
           </a:prstGeom>
           <a:solidFill>
-            <a:srgbClr val="0017C1"/>
+            <a:srgbClr val="0031D8"/>
           </a:solidFill>
           <a:ln/>
         </p:spPr>
@@ -7296,7 +7296,7 @@
             <a:r>
               <a:rPr lang="en-US" sz="1350" b="1" dirty="0">
                 <a:solidFill>
-                  <a:srgbClr val="0017C1"/>
+                  <a:srgbClr val="0031D8"/>
                 </a:solidFill>
                 <a:latin typeface="Noto Sans JP" pitchFamily="34" charset="0"/>
                 <a:ea typeface="Noto Sans JP" pitchFamily="34" charset="-122"/>
@@ -7723,7 +7723,7 @@
             </a:avLst>
           </a:prstGeom>
           <a:solidFill>
-            <a:srgbClr val="0017C1"/>
+            <a:srgbClr val="0031D8"/>
           </a:solidFill>
           <a:ln w="6350">
             <a:solidFill>
@@ -8026,7 +8026,7 @@
             </a:avLst>
           </a:prstGeom>
           <a:solidFill>
-            <a:srgbClr val="0017C1"/>
+            <a:srgbClr val="0031D8"/>
           </a:solidFill>
           <a:ln/>
         </p:spPr>
@@ -8091,7 +8091,7 @@
           </a:solidFill>
           <a:ln w="12700">
             <a:solidFill>
-              <a:srgbClr val="0017C1"/>
+              <a:srgbClr val="0031D8"/>
             </a:solidFill>
             <a:prstDash val="solid"/>
           </a:ln>
@@ -8124,7 +8124,7 @@
             <a:r>
               <a:rPr lang="en-US" sz="1050" b="1" dirty="0">
                 <a:solidFill>
-                  <a:srgbClr val="0017C1"/>
+                  <a:srgbClr val="0031D8"/>
                 </a:solidFill>
                 <a:latin typeface="Noto Sans JP" pitchFamily="34" charset="0"/>
                 <a:ea typeface="Noto Sans JP" pitchFamily="34" charset="-122"/>
@@ -8516,7 +8516,7 @@
             <a:r>
               <a:rPr lang="en-US" sz="2700" b="1" dirty="0">
                 <a:solidFill>
-                  <a:srgbClr val="0017C1"/>
+                  <a:srgbClr val="0031D8"/>
                 </a:solidFill>
                 <a:latin typeface="Noto Sans JP" pitchFamily="34" charset="0"/>
                 <a:ea typeface="Noto Sans JP" pitchFamily="34" charset="-122"/>
@@ -8620,7 +8620,7 @@
           </a:solidFill>
           <a:ln w="12700">
             <a:solidFill>
-              <a:srgbClr val="0017C1"/>
+              <a:srgbClr val="0031D8"/>
             </a:solidFill>
             <a:prstDash val="solid"/>
           </a:ln>
@@ -8653,7 +8653,7 @@
             <a:r>
               <a:rPr lang="en-US" sz="1350" b="1" dirty="0">
                 <a:solidFill>
-                  <a:srgbClr val="0017C1"/>
+                  <a:srgbClr val="0031D8"/>
                 </a:solidFill>
                 <a:latin typeface="Noto Sans JP" pitchFamily="34" charset="0"/>
                 <a:ea typeface="Noto Sans JP" pitchFamily="34" charset="-122"/>
@@ -8833,7 +8833,7 @@
             <a:avLst/>
           </a:prstGeom>
           <a:solidFill>
-            <a:srgbClr val="0017C1"/>
+            <a:srgbClr val="0031D8"/>
           </a:solidFill>
           <a:ln/>
         </p:spPr>
@@ -8953,7 +8953,7 @@
             <a:avLst/>
           </a:prstGeom>
           <a:solidFill>
-            <a:srgbClr val="0017C1"/>
+            <a:srgbClr val="0031D8"/>
           </a:solidFill>
           <a:ln/>
         </p:spPr>
@@ -9024,7 +9024,7 @@
             <a:r>
               <a:rPr lang="en-US" sz="1050" b="1" dirty="0">
                 <a:solidFill>
-                  <a:srgbClr val="0017C1"/>
+                  <a:srgbClr val="0031D8"/>
                 </a:solidFill>
                 <a:latin typeface="Noto Sans JP" pitchFamily="34" charset="0"/>
                 <a:ea typeface="Noto Sans JP" pitchFamily="34" charset="-122"/>
@@ -9528,7 +9528,7 @@
             <a:r>
               <a:rPr lang="en-US" sz="2700" b="1" dirty="0">
                 <a:solidFill>
-                  <a:srgbClr val="0017C1"/>
+                  <a:srgbClr val="0031D8"/>
                 </a:solidFill>
                 <a:latin typeface="Noto Sans JP" pitchFamily="34" charset="0"/>
                 <a:ea typeface="Noto Sans JP" pitchFamily="34" charset="-122"/>
@@ -9706,7 +9706,7 @@
                       <a:tailEnd type="none" w="med" len="med"/>
                     </a:lnB>
                     <a:solidFill>
-                      <a:srgbClr val="0017C1"/>
+                      <a:srgbClr val="0031D8"/>
                     </a:solidFill>
                   </a:tcPr>
                 </a:tc>
@@ -9774,7 +9774,7 @@
                       <a:tailEnd type="none" w="med" len="med"/>
                     </a:lnB>
                     <a:solidFill>
-                      <a:srgbClr val="0017C1"/>
+                      <a:srgbClr val="0031D8"/>
                     </a:solidFill>
                   </a:tcPr>
                 </a:tc>
@@ -9842,7 +9842,7 @@
                       <a:tailEnd type="none" w="med" len="med"/>
                     </a:lnB>
                     <a:solidFill>
-                      <a:srgbClr val="0017C1"/>
+                      <a:srgbClr val="0031D8"/>
                     </a:solidFill>
                   </a:tcPr>
                 </a:tc>
@@ -9910,7 +9910,7 @@
                       <a:tailEnd type="none" w="med" len="med"/>
                     </a:lnB>
                     <a:solidFill>
-                      <a:srgbClr val="0017C1"/>
+                      <a:srgbClr val="0031D8"/>
                     </a:solidFill>
                   </a:tcPr>
                 </a:tc>
@@ -10795,7 +10795,7 @@
             </a:avLst>
           </a:prstGeom>
           <a:solidFill>
-            <a:srgbClr val="0017C1"/>
+            <a:srgbClr val="0031D8"/>
           </a:solidFill>
           <a:ln/>
         </p:spPr>
@@ -10866,7 +10866,7 @@
             <a:r>
               <a:rPr lang="en-US" sz="4800" b="1" dirty="0">
                 <a:solidFill>
-                  <a:srgbClr val="0017C1"/>
+                  <a:srgbClr val="0031D8"/>
                 </a:solidFill>
                 <a:latin typeface="Noto Sans JP" pitchFamily="34" charset="0"/>
                 <a:ea typeface="Noto Sans JP" pitchFamily="34" charset="-122"/>
@@ -11715,7 +11715,7 @@
             <a:r>
               <a:rPr lang="en-US" sz="2700" b="1" dirty="0">
                 <a:solidFill>
-                  <a:srgbClr val="0017C1"/>
+                  <a:srgbClr val="0031D8"/>
                 </a:solidFill>
                 <a:latin typeface="Noto Sans JP" pitchFamily="34" charset="0"/>
                 <a:ea typeface="Noto Sans JP" pitchFamily="34" charset="-122"/>
@@ -11788,7 +11788,7 @@
             <a:r>
               <a:rPr lang="en-US" sz="1500" b="1" dirty="0">
                 <a:solidFill>
-                  <a:srgbClr val="0017C1"/>
+                  <a:srgbClr val="0031D8"/>
                 </a:solidFill>
                 <a:latin typeface="Noto Sans JP" pitchFamily="34" charset="0"/>
                 <a:ea typeface="Noto Sans JP" pitchFamily="34" charset="-122"/>
@@ -11827,7 +11827,7 @@
             <a:r>
               <a:rPr lang="en-US" sz="1500" b="1" dirty="0">
                 <a:solidFill>
-                  <a:srgbClr val="0017C1"/>
+                  <a:srgbClr val="0031D8"/>
                 </a:solidFill>
                 <a:latin typeface="Noto Sans JP" pitchFamily="34" charset="0"/>
                 <a:ea typeface="Noto Sans JP" pitchFamily="34" charset="-122"/>
@@ -11889,7 +11889,7 @@
             <a:r>
               <a:rPr lang="en-US" sz="1500" b="1" dirty="0">
                 <a:solidFill>
-                  <a:srgbClr val="0017C1"/>
+                  <a:srgbClr val="0031D8"/>
                 </a:solidFill>
                 <a:latin typeface="Noto Sans JP" pitchFamily="34" charset="0"/>
                 <a:ea typeface="Noto Sans JP" pitchFamily="34" charset="-122"/>
@@ -11990,7 +11990,7 @@
             <a:r>
               <a:rPr lang="en-US" sz="1500" b="1" dirty="0">
                 <a:solidFill>
-                  <a:srgbClr val="0017C1"/>
+                  <a:srgbClr val="0031D8"/>
                 </a:solidFill>
                 <a:latin typeface="Noto Sans JP" pitchFamily="34" charset="0"/>
                 <a:ea typeface="Noto Sans JP" pitchFamily="34" charset="-122"/>
@@ -12091,7 +12091,7 @@
             <a:r>
               <a:rPr lang="en-US" sz="1500" b="1" dirty="0">
                 <a:solidFill>
-                  <a:srgbClr val="0017C1"/>
+                  <a:srgbClr val="0031D8"/>
                 </a:solidFill>
                 <a:latin typeface="Noto Sans JP" pitchFamily="34" charset="0"/>
                 <a:ea typeface="Noto Sans JP" pitchFamily="34" charset="-122"/>
@@ -12192,7 +12192,7 @@
             <a:r>
               <a:rPr lang="en-US" sz="1500" b="1" dirty="0">
                 <a:solidFill>
-                  <a:srgbClr val="0017C1"/>
+                  <a:srgbClr val="0031D8"/>
                 </a:solidFill>
                 <a:latin typeface="Noto Sans JP" pitchFamily="34" charset="0"/>
                 <a:ea typeface="Noto Sans JP" pitchFamily="34" charset="-122"/>
@@ -12456,7 +12456,7 @@
             <a:r>
               <a:rPr lang="en-US" sz="2700" b="1" dirty="0">
                 <a:solidFill>
-                  <a:srgbClr val="0017C1"/>
+                  <a:srgbClr val="0031D8"/>
                 </a:solidFill>
                 <a:latin typeface="Noto Sans JP" pitchFamily="34" charset="0"/>
                 <a:ea typeface="Noto Sans JP" pitchFamily="34" charset="-122"/>
@@ -12721,7 +12721,7 @@
             <a:r>
               <a:rPr lang="en-US" sz="1050" b="1" dirty="0">
                 <a:solidFill>
-                  <a:srgbClr val="0017C1"/>
+                  <a:srgbClr val="0031D8"/>
                 </a:solidFill>
                 <a:latin typeface="Noto Sans JP" pitchFamily="34" charset="0"/>
                 <a:ea typeface="Noto Sans JP" pitchFamily="34" charset="-122"/>
@@ -12789,11 +12789,11 @@
             </a:avLst>
           </a:prstGeom>
           <a:solidFill>
-            <a:srgbClr val="0017C1"/>
+            <a:srgbClr val="0031D8"/>
           </a:solidFill>
           <a:ln w="19050">
             <a:solidFill>
-              <a:srgbClr val="0017C1"/>
+              <a:srgbClr val="0031D8"/>
             </a:solidFill>
             <a:prstDash val="solid"/>
           </a:ln>
@@ -13001,7 +13001,7 @@
           </a:solidFill>
           <a:ln w="19050">
             <a:solidFill>
-              <a:srgbClr val="0017C1"/>
+              <a:srgbClr val="0031D8"/>
             </a:solidFill>
             <a:prstDash val="solid"/>
           </a:ln>
@@ -13022,7 +13022,7 @@
             <a:avLst/>
           </a:prstGeom>
           <a:solidFill>
-            <a:srgbClr val="0017C1"/>
+            <a:srgbClr val="0031D8"/>
           </a:solidFill>
           <a:ln/>
         </p:spPr>
@@ -13196,7 +13196,7 @@
             <a:r>
               <a:rPr lang="en-US" sz="1050" dirty="0">
                 <a:solidFill>
-                  <a:srgbClr val="0017C1"/>
+                  <a:srgbClr val="0031D8"/>
                 </a:solidFill>
                 <a:latin typeface="Noto Sans JP" pitchFamily="34" charset="0"/>
                 <a:ea typeface="Noto Sans JP" pitchFamily="34" charset="-122"/>
@@ -13224,7 +13224,7 @@
             <a:r>
               <a:rPr lang="en-US" sz="1050" dirty="0">
                 <a:solidFill>
-                  <a:srgbClr val="0017C1"/>
+                  <a:srgbClr val="0031D8"/>
                 </a:solidFill>
                 <a:latin typeface="Noto Sans JP" pitchFamily="34" charset="0"/>
                 <a:ea typeface="Noto Sans JP" pitchFamily="34" charset="-122"/>
@@ -13502,7 +13502,7 @@
             <a:r>
               <a:rPr lang="en-US" sz="1800" b="1" spc="200" kern="0" dirty="0">
                 <a:solidFill>
-                  <a:srgbClr val="0017C1"/>
+                  <a:srgbClr val="0031D8"/>
                 </a:solidFill>
                 <a:latin typeface="Noto Sans JP" pitchFamily="34" charset="0"/>
                 <a:ea typeface="Noto Sans JP" pitchFamily="34" charset="-122"/>
@@ -13571,7 +13571,7 @@
             <a:avLst/>
           </a:prstGeom>
           <a:solidFill>
-            <a:srgbClr val="0017C1"/>
+            <a:srgbClr val="0031D8"/>
           </a:solidFill>
           <a:ln/>
         </p:spPr>
@@ -13805,7 +13805,7 @@
             <a:r>
               <a:rPr lang="en-US" sz="2700" b="1" dirty="0">
                 <a:solidFill>
-                  <a:srgbClr val="0017C1"/>
+                  <a:srgbClr val="0031D8"/>
                 </a:solidFill>
                 <a:latin typeface="Noto Sans JP" pitchFamily="34" charset="0"/>
                 <a:ea typeface="Noto Sans JP" pitchFamily="34" charset="-122"/>
@@ -14007,7 +14007,7 @@
             <a:avLst/>
           </a:prstGeom>
           <a:solidFill>
-            <a:srgbClr val="0017C1"/>
+            <a:srgbClr val="0031D8"/>
           </a:solidFill>
           <a:ln/>
         </p:spPr>
@@ -14324,7 +14324,7 @@
             <a:r>
               <a:rPr lang="en-US" sz="2700" b="1" dirty="0">
                 <a:solidFill>
-                  <a:srgbClr val="0017C1"/>
+                  <a:srgbClr val="0031D8"/>
                 </a:solidFill>
                 <a:latin typeface="Noto Sans JP" pitchFamily="34" charset="0"/>
                 <a:ea typeface="Noto Sans JP" pitchFamily="34" charset="-122"/>
@@ -14407,7 +14407,7 @@
             <a:avLst/>
           </a:prstGeom>
           <a:solidFill>
-            <a:srgbClr val="0017C1"/>
+            <a:srgbClr val="0031D8"/>
           </a:solidFill>
           <a:ln/>
         </p:spPr>
@@ -14439,7 +14439,7 @@
             <a:r>
               <a:rPr lang="en-US" sz="1500" b="1" dirty="0">
                 <a:solidFill>
-                  <a:srgbClr val="0017C1"/>
+                  <a:srgbClr val="0031D8"/>
                 </a:solidFill>
                 <a:latin typeface="Noto Sans JP" pitchFamily="34" charset="0"/>
                 <a:ea typeface="Noto Sans JP" pitchFamily="34" charset="-122"/>
@@ -14632,7 +14632,7 @@
           </a:solidFill>
           <a:ln w="25400">
             <a:solidFill>
-              <a:srgbClr val="0017C1"/>
+              <a:srgbClr val="0031D8"/>
             </a:solidFill>
             <a:prstDash val="solid"/>
           </a:ln>
@@ -14653,7 +14653,7 @@
             <a:avLst/>
           </a:prstGeom>
           <a:solidFill>
-            <a:srgbClr val="0017C1"/>
+            <a:srgbClr val="0031D8"/>
           </a:solidFill>
           <a:ln/>
         </p:spPr>
@@ -14685,7 +14685,7 @@
             <a:r>
               <a:rPr lang="en-US" sz="1800" b="1" dirty="0">
                 <a:solidFill>
-                  <a:srgbClr val="0017C1"/>
+                  <a:srgbClr val="0031D8"/>
                 </a:solidFill>
                 <a:latin typeface="Noto Sans JP" pitchFamily="34" charset="0"/>
                 <a:ea typeface="Noto Sans JP" pitchFamily="34" charset="-122"/>
@@ -15043,7 +15043,7 @@
             <a:r>
               <a:rPr lang="en-US" sz="2700" b="1" dirty="0">
                 <a:solidFill>
-                  <a:srgbClr val="0017C1"/>
+                  <a:srgbClr val="0031D8"/>
                 </a:solidFill>
                 <a:latin typeface="Noto Sans JP" pitchFamily="34" charset="0"/>
                 <a:ea typeface="Noto Sans JP" pitchFamily="34" charset="-122"/>
@@ -15182,7 +15182,7 @@
             <a:r>
               <a:rPr lang="en-US" sz="1800" b="1" dirty="0">
                 <a:solidFill>
-                  <a:srgbClr val="0017C1"/>
+                  <a:srgbClr val="0031D8"/>
                 </a:solidFill>
                 <a:latin typeface="Noto Sans JP" pitchFamily="34" charset="0"/>
                 <a:ea typeface="Noto Sans JP" pitchFamily="34" charset="-122"/>
@@ -15488,7 +15488,7 @@
             <a:r>
               <a:rPr lang="en-US" sz="2700" b="1" dirty="0">
                 <a:solidFill>
-                  <a:srgbClr val="0017C1"/>
+                  <a:srgbClr val="0031D8"/>
                 </a:solidFill>
                 <a:latin typeface="Noto Sans JP" pitchFamily="34" charset="0"/>
                 <a:ea typeface="Noto Sans JP" pitchFamily="34" charset="-122"/>
@@ -15571,7 +15571,7 @@
             <a:avLst/>
           </a:prstGeom>
           <a:solidFill>
-            <a:srgbClr val="0017C1"/>
+            <a:srgbClr val="0031D8"/>
           </a:solidFill>
           <a:ln/>
         </p:spPr>
@@ -15603,7 +15603,7 @@
             <a:r>
               <a:rPr lang="en-US" sz="2700" b="1" dirty="0">
                 <a:solidFill>
-                  <a:srgbClr val="0017C1"/>
+                  <a:srgbClr val="0031D8"/>
                 </a:solidFill>
                 <a:latin typeface="Noto Sans JP" pitchFamily="34" charset="0"/>
                 <a:ea typeface="Noto Sans JP" pitchFamily="34" charset="-122"/>
@@ -15691,7 +15691,7 @@
             <a:avLst/>
           </a:prstGeom>
           <a:solidFill>
-            <a:srgbClr val="0017C1"/>
+            <a:srgbClr val="0031D8"/>
           </a:solidFill>
           <a:ln/>
         </p:spPr>
@@ -15723,7 +15723,7 @@
             <a:r>
               <a:rPr lang="en-US" sz="2700" b="1" dirty="0">
                 <a:solidFill>
-                  <a:srgbClr val="0017C1"/>
+                  <a:srgbClr val="0031D8"/>
                 </a:solidFill>
                 <a:latin typeface="Noto Sans JP" pitchFamily="34" charset="0"/>
                 <a:ea typeface="Noto Sans JP" pitchFamily="34" charset="-122"/>
@@ -15811,7 +15811,7 @@
             <a:avLst/>
           </a:prstGeom>
           <a:solidFill>
-            <a:srgbClr val="0017C1"/>
+            <a:srgbClr val="0031D8"/>
           </a:solidFill>
           <a:ln/>
         </p:spPr>
@@ -15843,7 +15843,7 @@
             <a:r>
               <a:rPr lang="en-US" sz="2700" b="1" dirty="0">
                 <a:solidFill>
-                  <a:srgbClr val="0017C1"/>
+                  <a:srgbClr val="0031D8"/>
                 </a:solidFill>
                 <a:latin typeface="Noto Sans JP" pitchFamily="34" charset="0"/>
                 <a:ea typeface="Noto Sans JP" pitchFamily="34" charset="-122"/>
@@ -15911,7 +15911,7 @@
             </a:avLst>
           </a:prstGeom>
           <a:solidFill>
-            <a:srgbClr val="0017C1"/>
+            <a:srgbClr val="0031D8"/>
           </a:solidFill>
           <a:ln/>
         </p:spPr>
@@ -16145,7 +16145,7 @@
             <a:r>
               <a:rPr lang="en-US" sz="2700" b="1" dirty="0">
                 <a:solidFill>
-                  <a:srgbClr val="0017C1"/>
+                  <a:srgbClr val="0031D8"/>
                 </a:solidFill>
                 <a:latin typeface="Noto Sans JP" pitchFamily="34" charset="0"/>
                 <a:ea typeface="Noto Sans JP" pitchFamily="34" charset="-122"/>
@@ -16218,7 +16218,7 @@
             <a:r>
               <a:rPr lang="en-US" sz="4800" b="1" dirty="0">
                 <a:solidFill>
-                  <a:srgbClr val="0017C1"/>
+                  <a:srgbClr val="0031D8"/>
                 </a:solidFill>
                 <a:latin typeface="Noto Sans JP" pitchFamily="34" charset="0"/>
                 <a:ea typeface="Noto Sans JP" pitchFamily="34" charset="-122"/>
@@ -16619,7 +16619,7 @@
             <a:r>
               <a:rPr lang="en-US" sz="2700" b="1" dirty="0">
                 <a:solidFill>
-                  <a:srgbClr val="0017C1"/>
+                  <a:srgbClr val="0031D8"/>
                 </a:solidFill>
                 <a:latin typeface="Noto Sans JP" pitchFamily="34" charset="0"/>
                 <a:ea typeface="Noto Sans JP" pitchFamily="34" charset="-122"/>
@@ -16826,14 +16826,39 @@
             </a:avLst>
           </a:prstGeom>
           <a:solidFill>
-            <a:srgbClr val="0017C1"/>
+            <a:srgbClr val="F2F2F2"/>
           </a:solidFill>
-          <a:ln/>
-        </p:spPr>
-      </p:sp>
-      <p:sp>
-        <p:nvSpPr>
-          <p:cNvPr id="9" name="Text 7"/>
+          <a:ln w="12700">
+            <a:solidFill>
+              <a:srgbClr val="0031D8"/>
+            </a:solidFill>
+            <a:prstDash val="solid"/>
+          </a:ln>
+        </p:spPr>
+      </p:sp>
+      <p:sp>
+        <p:nvSpPr>
+          <p:cNvPr id="9" name="Shape 7"/>
+          <p:cNvSpPr/>
+          <p:nvPr/>
+        </p:nvSpPr>
+        <p:spPr>
+          <a:xfrm>
+            <a:off x="4267109" y="1417320"/>
+            <a:ext cx="3657478" cy="38405"/>
+          </a:xfrm>
+          <a:prstGeom prst="rect">
+            <a:avLst/>
+          </a:prstGeom>
+          <a:solidFill>
+            <a:srgbClr val="0031D8"/>
+          </a:solidFill>
+          <a:ln/>
+        </p:spPr>
+      </p:sp>
+      <p:sp>
+        <p:nvSpPr>
+          <p:cNvPr id="10" name="Text 8"/>
           <p:cNvSpPr/>
           <p:nvPr/>
         </p:nvSpPr>
@@ -16858,7 +16883,7 @@
             <a:r>
               <a:rPr lang="en-US" sz="1050" dirty="0">
                 <a:solidFill>
-                  <a:srgbClr val="E8F1FE"/>
+                  <a:srgbClr val="666666"/>
                 </a:solidFill>
                 <a:latin typeface="Noto Sans JP" pitchFamily="34" charset="0"/>
                 <a:ea typeface="Noto Sans JP" pitchFamily="34" charset="-122"/>
@@ -16872,7 +16897,7 @@
       </p:sp>
       <p:sp>
         <p:nvSpPr>
-          <p:cNvPr id="10" name="Text 8"/>
+          <p:cNvPr id="11" name="Text 9"/>
           <p:cNvSpPr/>
           <p:nvPr/>
         </p:nvSpPr>
@@ -16897,13 +16922,13 @@
             <a:r>
               <a:rPr lang="en-US" sz="4000" b="1" dirty="0">
                 <a:solidFill>
-                  <a:srgbClr val="FFFFFF"/>
-                </a:solidFill>
-                <a:latin typeface="Noto Sans JP" pitchFamily="34" charset="0"/>
-                <a:ea typeface="Noto Sans JP" pitchFamily="34" charset="-122"/>
-                <a:cs typeface="Noto Sans JP" pitchFamily="34" charset="-120"/>
-              </a:rPr>
-              <a:t>12</a:t>
+                  <a:srgbClr val="0031D8"/>
+                </a:solidFill>
+                <a:latin typeface="Noto Sans JP" pitchFamily="34" charset="0"/>
+                <a:ea typeface="Noto Sans JP" pitchFamily="34" charset="-122"/>
+                <a:cs typeface="Noto Sans JP" pitchFamily="34" charset="-120"/>
+              </a:rPr>
+              <a:t>20</a:t>
             </a:r>
             <a:endParaRPr lang="en-US" sz="4000" dirty="0"/>
           </a:p>
@@ -16911,7 +16936,7 @@
       </p:sp>
       <p:sp>
         <p:nvSpPr>
-          <p:cNvPr id="11" name="Text 9"/>
+          <p:cNvPr id="12" name="Text 10"/>
           <p:cNvSpPr/>
           <p:nvPr/>
         </p:nvSpPr>
@@ -16936,13 +16961,13 @@
             <a:r>
               <a:rPr lang="en-US" sz="1050" dirty="0">
                 <a:solidFill>
-                  <a:srgbClr val="E8F1FE"/>
-                </a:solidFill>
-                <a:latin typeface="Noto Sans JP" pitchFamily="34" charset="0"/>
-                <a:ea typeface="Noto Sans JP" pitchFamily="34" charset="-122"/>
-                <a:cs typeface="Noto Sans JP" pitchFamily="34" charset="-120"/>
-              </a:rPr>
-              <a:t>再利用可</a:t>
+                  <a:srgbClr val="666666"/>
+                </a:solidFill>
+                <a:latin typeface="Noto Sans JP" pitchFamily="34" charset="0"/>
+                <a:ea typeface="Noto Sans JP" pitchFamily="34" charset="-122"/>
+                <a:cs typeface="Noto Sans JP" pitchFamily="34" charset="-120"/>
+              </a:rPr>
+              <a:t>自作14+公式6</a:t>
             </a:r>
             <a:endParaRPr lang="en-US" sz="1050" dirty="0"/>
           </a:p>
@@ -16950,7 +16975,7 @@
       </p:sp>
       <p:sp>
         <p:nvSpPr>
-          <p:cNvPr id="12" name="Shape 10"/>
+          <p:cNvPr id="13" name="Shape 11"/>
           <p:cNvSpPr/>
           <p:nvPr/>
         </p:nvSpPr>
@@ -16977,7 +17002,7 @@
       </p:sp>
       <p:sp>
         <p:nvSpPr>
-          <p:cNvPr id="13" name="Text 11"/>
+          <p:cNvPr id="14" name="Text 12"/>
           <p:cNvSpPr/>
           <p:nvPr/>
         </p:nvSpPr>
@@ -17016,7 +17041,7 @@
       </p:sp>
       <p:sp>
         <p:nvSpPr>
-          <p:cNvPr id="14" name="Text 12"/>
+          <p:cNvPr id="15" name="Text 13"/>
           <p:cNvSpPr/>
           <p:nvPr/>
         </p:nvSpPr>
@@ -17055,7 +17080,7 @@
       </p:sp>
       <p:sp>
         <p:nvSpPr>
-          <p:cNvPr id="15" name="Text 13"/>
+          <p:cNvPr id="16" name="Text 14"/>
           <p:cNvSpPr/>
           <p:nvPr/>
         </p:nvSpPr>
@@ -17094,7 +17119,7 @@
       </p:sp>
       <p:sp>
         <p:nvSpPr>
-          <p:cNvPr id="16" name="Shape 14"/>
+          <p:cNvPr id="17" name="Shape 15"/>
           <p:cNvSpPr/>
           <p:nvPr/>
         </p:nvSpPr>
@@ -17121,7 +17146,7 @@
       </p:sp>
       <p:sp>
         <p:nvSpPr>
-          <p:cNvPr id="17" name="Text 15"/>
+          <p:cNvPr id="18" name="Text 16"/>
           <p:cNvSpPr/>
           <p:nvPr/>
         </p:nvSpPr>
@@ -17160,7 +17185,7 @@
       </p:sp>
       <p:sp>
         <p:nvSpPr>
-          <p:cNvPr id="18" name="Text 16"/>
+          <p:cNvPr id="19" name="Text 17"/>
           <p:cNvSpPr/>
           <p:nvPr/>
         </p:nvSpPr>
@@ -17191,7 +17216,7 @@
                 <a:ea typeface="Noto Sans JP" pitchFamily="34" charset="-122"/>
                 <a:cs typeface="Noto Sans JP" pitchFamily="34" charset="-120"/>
               </a:rPr>
-              <a:t>5</a:t>
+              <a:t>8</a:t>
             </a:r>
             <a:endParaRPr lang="en-US" sz="4000" dirty="0"/>
           </a:p>
@@ -17199,7 +17224,7 @@
       </p:sp>
       <p:sp>
         <p:nvSpPr>
-          <p:cNvPr id="19" name="Text 17"/>
+          <p:cNvPr id="20" name="Text 18"/>
           <p:cNvSpPr/>
           <p:nvPr/>
         </p:nvSpPr>
@@ -17238,7 +17263,7 @@
       </p:sp>
       <p:sp>
         <p:nvSpPr>
-          <p:cNvPr id="20" name="Shape 18"/>
+          <p:cNvPr id="21" name="Shape 19"/>
           <p:cNvSpPr/>
           <p:nvPr/>
         </p:nvSpPr>
@@ -17265,7 +17290,7 @@
       </p:sp>
       <p:sp>
         <p:nvSpPr>
-          <p:cNvPr id="21" name="Text 19"/>
+          <p:cNvPr id="22" name="Text 20"/>
           <p:cNvSpPr/>
           <p:nvPr/>
         </p:nvSpPr>
@@ -17304,7 +17329,7 @@
       </p:sp>
       <p:sp>
         <p:nvSpPr>
-          <p:cNvPr id="22" name="Text 20"/>
+          <p:cNvPr id="23" name="Text 21"/>
           <p:cNvSpPr/>
           <p:nvPr/>
         </p:nvSpPr>
@@ -17343,7 +17368,7 @@
       </p:sp>
       <p:sp>
         <p:nvSpPr>
-          <p:cNvPr id="23" name="Text 21"/>
+          <p:cNvPr id="24" name="Text 22"/>
           <p:cNvSpPr/>
           <p:nvPr/>
         </p:nvSpPr>
@@ -17382,7 +17407,7 @@
       </p:sp>
       <p:sp>
         <p:nvSpPr>
-          <p:cNvPr id="24" name="Shape 22"/>
+          <p:cNvPr id="25" name="Shape 23"/>
           <p:cNvSpPr/>
           <p:nvPr/>
         </p:nvSpPr>
@@ -17409,7 +17434,7 @@
       </p:sp>
       <p:sp>
         <p:nvSpPr>
-          <p:cNvPr id="25" name="Text 23"/>
+          <p:cNvPr id="26" name="Text 24"/>
           <p:cNvSpPr/>
           <p:nvPr/>
         </p:nvSpPr>
@@ -17448,7 +17473,7 @@
       </p:sp>
       <p:sp>
         <p:nvSpPr>
-          <p:cNvPr id="26" name="Text 24"/>
+          <p:cNvPr id="27" name="Text 25"/>
           <p:cNvSpPr/>
           <p:nvPr/>
         </p:nvSpPr>
@@ -17487,7 +17512,7 @@
       </p:sp>
       <p:sp>
         <p:nvSpPr>
-          <p:cNvPr id="27" name="Text 25"/>
+          <p:cNvPr id="28" name="Text 26"/>
           <p:cNvSpPr/>
           <p:nvPr/>
         </p:nvSpPr>
@@ -17526,7 +17551,7 @@
       </p:sp>
       <p:sp>
         <p:nvSpPr>
-          <p:cNvPr id="28" name="Shape 26"/>
+          <p:cNvPr id="29" name="Shape 27"/>
           <p:cNvSpPr/>
           <p:nvPr/>
         </p:nvSpPr>
@@ -17549,7 +17574,7 @@
       </p:sp>
       <p:sp>
         <p:nvSpPr>
-          <p:cNvPr id="29" name="Text 27"/>
+          <p:cNvPr id="30" name="Text 28"/>
           <p:cNvSpPr/>
           <p:nvPr/>
         </p:nvSpPr>
@@ -17588,7 +17613,7 @@
       </p:sp>
       <p:sp>
         <p:nvSpPr>
-          <p:cNvPr id="30" name="Text 28"/>
+          <p:cNvPr id="31" name="Text 29"/>
           <p:cNvSpPr/>
           <p:nvPr/>
         </p:nvSpPr>
@@ -17627,7 +17652,7 @@
       </p:sp>
       <p:sp>
         <p:nvSpPr>
-          <p:cNvPr id="31" name="Text 29"/>
+          <p:cNvPr id="32" name="Text 30"/>
           <p:cNvSpPr/>
           <p:nvPr/>
         </p:nvSpPr>
@@ -17666,7 +17691,7 @@
       </p:sp>
       <p:sp>
         <p:nvSpPr>
-          <p:cNvPr id="32" name="Text 30"/>
+          <p:cNvPr id="33" name="Text 31"/>
           <p:cNvSpPr/>
           <p:nvPr/>
         </p:nvSpPr>
@@ -17722,28 +17747,28 @@
         <a:sysClr val="window" lastClr="FFFFFF"/>
       </a:lt1>
       <a:dk2>
-        <a:srgbClr val="44546A"/>
+        <a:srgbClr val="333333"/>
       </a:dk2>
       <a:lt2>
-        <a:srgbClr val="E7E6E6"/>
+        <a:srgbClr val="E6E6E6"/>
       </a:lt2>
       <a:accent1>
-        <a:srgbClr val="4472C4"/>
+        <a:srgbClr val="0031D8"/>
       </a:accent1>
       <a:accent2>
-        <a:srgbClr val="ED7D31"/>
+        <a:srgbClr val="0877D7"/>
       </a:accent2>
       <a:accent3>
-        <a:srgbClr val="A5A5A5"/>
+        <a:srgbClr val="008299"/>
       </a:accent3>
       <a:accent4>
-        <a:srgbClr val="FFC000"/>
+        <a:srgbClr val="1D8B56"/>
       </a:accent4>
       <a:accent5>
-        <a:srgbClr val="5B9BD5"/>
+        <a:srgbClr val="E25100"/>
       </a:accent5>
       <a:accent6>
-        <a:srgbClr val="70AD47"/>
+        <a:srgbClr val="FA0000"/>
       </a:accent6>
       <a:hlink>
         <a:srgbClr val="0563C1"/>

</xml_diff>